<commit_message>
Refresh golden examples from CI renderer and release 2.8.2
Co-authored-by: Cursor <cursoragent@cursor.com>
</commit_message>
<xml_diff>
--- a/plugins/gradient-cio/assets/examples/gradient-gips-standards.pptx
+++ b/plugins/gradient-cio/assets/examples/gradient-gips-standards.pptx
@@ -1,20 +1,20 @@
 
 <file path=ppt/presentation.xml><?xml version="1.0" encoding="utf-8"?>
-<p:presentation xmlns:a="http://schemas.openxmlformats.org/drawingml/2006/main" xmlns:r="http://schemas.openxmlformats.org/officeDocument/2006/relationships" xmlns:p="http://schemas.openxmlformats.org/presentationml/2006/main" saveSubsetFonts="1" autoCompressPictures="0">
-  <p:sldMasterIdLst>
-    <p:sldMasterId id="2147483648" r:id="rId1"/>
-  </p:sldMasterIdLst>
-  <p:sldIdLst>
-    <p:sldId id="256" r:id="rId7"/>
-    <p:sldId id="257" r:id="rId8"/>
-    <p:sldId id="258" r:id="rId9"/>
-    <p:sldId id="259" r:id="rId10"/>
-    <p:sldId id="260" r:id="rId11"/>
-    <p:sldId id="261" r:id="rId12"/>
-  </p:sldIdLst>
-  <p:sldSz cx="12191695" cy="6858000" type="screen4x3"/>
-  <p:notesSz cx="6858000" cy="9144000"/>
-  <p:defaultTextStyle>
+<ns0:presentation xmlns:a="http://schemas.openxmlformats.org/drawingml/2006/main" xmlns:ns0="http://schemas.openxmlformats.org/presentationml/2006/main" xmlns:ns1="http://schemas.openxmlformats.org/officeDocument/2006/relationships" saveSubsetFonts="1" autoCompressPictures="0">
+  <ns0:sldMasterIdLst>
+    <ns0:sldMasterId id="2147483648" ns1:id="rId1"/>
+  </ns0:sldMasterIdLst>
+  <ns0:sldIdLst>
+    <ns0:sldId id="256" ns1:id="rId7"/>
+    <ns0:sldId id="257" ns1:id="rId8"/>
+    <ns0:sldId id="258" ns1:id="rId9"/>
+    <ns0:sldId id="259" ns1:id="rId10"/>
+    <ns0:sldId id="260" ns1:id="rId11"/>
+    <ns0:sldId id="261" ns1:id="rId12"/>
+  </ns0:sldIdLst>
+  <ns0:sldSz cx="12191695" cy="6858000" type="screen16x9"/>
+  <ns0:notesSz cx="6858000" cy="9144000"/>
+  <ns0:defaultTextStyle>
     <a:defPPr>
       <a:defRPr lang="en-US"/>
     </a:defPPr>
@@ -108,8 +108,8 @@
         <a:cs typeface="+mn-cs"/>
       </a:defRPr>
     </a:lvl9pPr>
-  </p:defaultTextStyle>
-</p:presentation>
+  </ns0:defaultTextStyle>
+</ns0:presentation>
 </file>
 
 <file path=ppt/slideLayouts/slideLayout1.xml><?xml version="1.0" encoding="utf-8"?>
@@ -2250,7 +2250,11 @@
           <a:bodyPr rtlCol="0" anchor="ctr"/>
           <a:lstStyle/>
           <a:p>
-            <a:pPr algn="ctr"/>
+            <a:pPr algn="ctr">
+              <a:defRPr>
+                <a:latin typeface="Inter"/>
+              </a:defRPr>
+            </a:pPr>
           </a:p>
         </p:txBody>
       </p:sp>
@@ -2295,7 +2299,11 @@
           <a:bodyPr rtlCol="0" anchor="ctr"/>
           <a:lstStyle/>
           <a:p>
-            <a:pPr algn="ctr"/>
+            <a:pPr algn="ctr">
+              <a:defRPr>
+                <a:latin typeface="Inter"/>
+              </a:defRPr>
+            </a:pPr>
           </a:p>
         </p:txBody>
       </p:sp>
@@ -2308,7 +2316,7 @@
         <p:spPr>
           <a:xfrm>
             <a:off x="685800" y="457200"/>
-            <a:ext cx="2743200" cy="320040"/>
+            <a:ext cx="4754880" cy="320040"/>
           </a:xfrm>
           <a:prstGeom prst="rect">
             <a:avLst/>
@@ -2333,6 +2341,9 @@
               </a:defRPr>
             </a:pPr>
             <a:r>
+              <a:rPr>
+                <a:latin typeface="Inter"/>
+              </a:rPr>
               <a:t>GradientCIO</a:t>
             </a:r>
           </a:p>
@@ -2372,6 +2383,9 @@
               </a:defRPr>
             </a:pPr>
             <a:r>
+              <a:rPr>
+                <a:latin typeface="Inter"/>
+              </a:rPr>
               <a:t>GIPS BRIEFING NOTE</a:t>
             </a:r>
           </a:p>
@@ -2411,6 +2425,9 @@
               </a:defRPr>
             </a:pPr>
             <a:r>
+              <a:rPr>
+                <a:latin typeface="Inter"/>
+              </a:rPr>
               <a:t>What must a GIPS Composite Report disclose about fees?</a:t>
             </a:r>
           </a:p>
@@ -2450,6 +2467,9 @@
               </a:defRPr>
             </a:pPr>
             <a:r>
+              <a:rPr>
+                <a:latin typeface="Inter"/>
+              </a:rPr>
               <a:t>2020 GIPS standards · firms</a:t>
             </a:r>
           </a:p>
@@ -2496,7 +2516,11 @@
           <a:bodyPr rtlCol="0" anchor="ctr"/>
           <a:lstStyle/>
           <a:p>
-            <a:pPr algn="ctr"/>
+            <a:pPr algn="ctr">
+              <a:defRPr>
+                <a:latin typeface="Inter"/>
+              </a:defRPr>
+            </a:pPr>
           </a:p>
         </p:txBody>
       </p:sp>
@@ -2534,6 +2558,9 @@
               </a:defRPr>
             </a:pPr>
             <a:r>
+              <a:rPr>
+                <a:latin typeface="Inter"/>
+              </a:rPr>
               <a:t>Layout test — not legal advice</a:t>
             </a:r>
           </a:p>
@@ -2547,8 +2574,8 @@
         </p:nvSpPr>
         <p:spPr>
           <a:xfrm>
-            <a:off x="9875520" y="6473952"/>
-            <a:ext cx="1645920" cy="182880"/>
+            <a:off x="8778240" y="6473952"/>
+            <a:ext cx="2743200" cy="182880"/>
           </a:xfrm>
           <a:prstGeom prst="rect">
             <a:avLst/>
@@ -2573,6 +2600,9 @@
               </a:defRPr>
             </a:pPr>
             <a:r>
+              <a:rPr>
+                <a:latin typeface="Inter"/>
+              </a:rPr>
               <a:t>GradientCIO.com</a:t>
             </a:r>
           </a:p>
@@ -2637,7 +2667,11 @@
           <a:bodyPr rtlCol="0" anchor="ctr"/>
           <a:lstStyle/>
           <a:p>
-            <a:pPr algn="ctr"/>
+            <a:pPr algn="ctr">
+              <a:defRPr>
+                <a:latin typeface="Inter"/>
+              </a:defRPr>
+            </a:pPr>
           </a:p>
         </p:txBody>
       </p:sp>
@@ -2675,6 +2709,9 @@
               </a:defRPr>
             </a:pPr>
             <a:r>
+              <a:rPr>
+                <a:latin typeface="Inter"/>
+              </a:rPr>
               <a:t>Answer</a:t>
             </a:r>
           </a:p>
@@ -2721,7 +2758,11 @@
           <a:bodyPr rtlCol="0" anchor="ctr"/>
           <a:lstStyle/>
           <a:p>
-            <a:pPr algn="ctr"/>
+            <a:pPr algn="ctr">
+              <a:defRPr>
+                <a:latin typeface="Inter"/>
+              </a:defRPr>
+            </a:pPr>
           </a:p>
         </p:txBody>
       </p:sp>
@@ -2766,7 +2807,11 @@
           <a:bodyPr rtlCol="0" anchor="ctr"/>
           <a:lstStyle/>
           <a:p>
-            <a:pPr algn="ctr"/>
+            <a:pPr algn="ctr">
+              <a:defRPr>
+                <a:latin typeface="Inter"/>
+              </a:defRPr>
+            </a:pPr>
           </a:p>
         </p:txBody>
       </p:sp>
@@ -2804,6 +2849,9 @@
               </a:defRPr>
             </a:pPr>
             <a:r>
+              <a:rPr>
+                <a:latin typeface="Inter"/>
+              </a:rPr>
               <a:t>01</a:t>
             </a:r>
           </a:p>
@@ -2850,7 +2898,11 @@
           <a:bodyPr rtlCol="0" anchor="ctr"/>
           <a:lstStyle/>
           <a:p>
-            <a:pPr algn="ctr"/>
+            <a:pPr algn="ctr">
+              <a:defRPr>
+                <a:latin typeface="Inter"/>
+              </a:defRPr>
+            </a:pPr>
           </a:p>
         </p:txBody>
       </p:sp>
@@ -2895,7 +2947,11 @@
           <a:bodyPr rtlCol="0" anchor="ctr"/>
           <a:lstStyle/>
           <a:p>
-            <a:pPr algn="ctr"/>
+            <a:pPr algn="ctr">
+              <a:defRPr>
+                <a:latin typeface="Inter"/>
+              </a:defRPr>
+            </a:pPr>
           </a:p>
         </p:txBody>
       </p:sp>
@@ -2933,6 +2989,9 @@
               </a:defRPr>
             </a:pPr>
             <a:r>
+              <a:rPr>
+                <a:latin typeface="Inter"/>
+              </a:rPr>
               <a:t>Short answer</a:t>
             </a:r>
           </a:p>
@@ -2972,6 +3031,9 @@
               </a:defRPr>
             </a:pPr>
             <a:r>
+              <a:rPr>
+                <a:latin typeface="Inter"/>
+              </a:rPr>
               <a:t>Disclose the fee schedule (4.C.11) and label returns gross or net (4.A.3) [S1].</a:t>
             </a:r>
           </a:p>
@@ -3011,6 +3073,9 @@
               </a:defRPr>
             </a:pPr>
             <a:r>
+              <a:rPr>
+                <a:latin typeface="Inter"/>
+              </a:rPr>
               <a:t>A GIPS Composite Report must disclose the fee schedule appropriate to the report's prospective client (4.C.11) and state whether returns are gross or net of fees, with what fees were deducted.</a:t>
             </a:r>
           </a:p>
@@ -3057,7 +3122,11 @@
           <a:bodyPr rtlCol="0" anchor="ctr"/>
           <a:lstStyle/>
           <a:p>
-            <a:pPr algn="ctr"/>
+            <a:pPr algn="ctr">
+              <a:defRPr>
+                <a:latin typeface="Inter"/>
+              </a:defRPr>
+            </a:pPr>
           </a:p>
         </p:txBody>
       </p:sp>
@@ -3095,6 +3164,9 @@
               </a:defRPr>
             </a:pPr>
             <a:r>
+              <a:rPr>
+                <a:latin typeface="Inter"/>
+              </a:rPr>
               <a:t>Sources: S1</a:t>
             </a:r>
           </a:p>
@@ -3134,7 +3206,10 @@
               </a:defRPr>
             </a:pPr>
             <a:r>
-              <a:t>Layout test — not legal advice</a:t>
+              <a:rPr>
+                <a:latin typeface="Inter"/>
+              </a:rPr>
+              <a:t>Layout test — not legal advice · Data as of References as of October 2026</a:t>
             </a:r>
           </a:p>
         </p:txBody>
@@ -3173,6 +3248,9 @@
               </a:defRPr>
             </a:pPr>
             <a:r>
+              <a:rPr>
+                <a:latin typeface="Inter"/>
+              </a:rPr>
               <a:t>2</a:t>
             </a:r>
           </a:p>
@@ -3237,7 +3315,11 @@
           <a:bodyPr rtlCol="0" anchor="ctr"/>
           <a:lstStyle/>
           <a:p>
-            <a:pPr algn="ctr"/>
+            <a:pPr algn="ctr">
+              <a:defRPr>
+                <a:latin typeface="Inter"/>
+              </a:defRPr>
+            </a:pPr>
           </a:p>
         </p:txBody>
       </p:sp>
@@ -3275,6 +3357,9 @@
               </a:defRPr>
             </a:pPr>
             <a:r>
+              <a:rPr>
+                <a:latin typeface="Inter"/>
+              </a:rPr>
               <a:t>Requirements</a:t>
             </a:r>
           </a:p>
@@ -3321,7 +3406,11 @@
           <a:bodyPr rtlCol="0" anchor="ctr"/>
           <a:lstStyle/>
           <a:p>
-            <a:pPr algn="ctr"/>
+            <a:pPr algn="ctr">
+              <a:defRPr>
+                <a:latin typeface="Inter"/>
+              </a:defRPr>
+            </a:pPr>
           </a:p>
         </p:txBody>
       </p:sp>
@@ -3366,7 +3455,11 @@
           <a:bodyPr rtlCol="0" anchor="ctr"/>
           <a:lstStyle/>
           <a:p>
-            <a:pPr algn="ctr"/>
+            <a:pPr algn="ctr">
+              <a:defRPr>
+                <a:latin typeface="Inter"/>
+              </a:defRPr>
+            </a:pPr>
           </a:p>
         </p:txBody>
       </p:sp>
@@ -3404,6 +3497,9 @@
               </a:defRPr>
             </a:pPr>
             <a:r>
+              <a:rPr>
+                <a:latin typeface="Inter"/>
+              </a:rPr>
               <a:t>02</a:t>
             </a:r>
           </a:p>
@@ -3443,16 +3539,25 @@
               </a:defRPr>
             </a:pPr>
             <a:r>
+              <a:rPr>
+                <a:latin typeface="Inter"/>
+              </a:rPr>
               <a:t>·  Requirement  ·  Provision  ·  Applies to  ·  Notes  · </a:t>
             </a:r>
             <a:br/>
             <a:br/>
             <a:r>
+              <a:rPr>
+                <a:latin typeface="Inter"/>
+              </a:rPr>
               <a:t> ·  Current fee schedule  ·  4.C.11  ·  Composite reports  ·  Appropriate to the prospective client  · </a:t>
             </a:r>
             <a:br/>
             <a:br/>
             <a:r>
+              <a:rPr>
+                <a:latin typeface="Inter"/>
+              </a:rPr>
               <a:t> ·  Gross/net labelling  ·  4.A.3  ·  All reports  ·  Label every return series  ·</a:t>
             </a:r>
           </a:p>
@@ -3499,7 +3604,11 @@
           <a:bodyPr rtlCol="0" anchor="ctr"/>
           <a:lstStyle/>
           <a:p>
-            <a:pPr algn="ctr"/>
+            <a:pPr algn="ctr">
+              <a:defRPr>
+                <a:latin typeface="Inter"/>
+              </a:defRPr>
+            </a:pPr>
           </a:p>
         </p:txBody>
       </p:sp>
@@ -3537,6 +3646,9 @@
               </a:defRPr>
             </a:pPr>
             <a:r>
+              <a:rPr>
+                <a:latin typeface="Inter"/>
+              </a:rPr>
               <a:t>Sources: none cited</a:t>
             </a:r>
           </a:p>
@@ -3576,7 +3688,10 @@
               </a:defRPr>
             </a:pPr>
             <a:r>
-              <a:t>Layout test — not legal advice</a:t>
+              <a:rPr>
+                <a:latin typeface="Inter"/>
+              </a:rPr>
+              <a:t>Layout test — not legal advice · Data as of References as of October 2026</a:t>
             </a:r>
           </a:p>
         </p:txBody>
@@ -3615,6 +3730,9 @@
               </a:defRPr>
             </a:pPr>
             <a:r>
+              <a:rPr>
+                <a:latin typeface="Inter"/>
+              </a:rPr>
               <a:t>3</a:t>
             </a:r>
           </a:p>
@@ -3679,7 +3797,11 @@
           <a:bodyPr rtlCol="0" anchor="ctr"/>
           <a:lstStyle/>
           <a:p>
-            <a:pPr algn="ctr"/>
+            <a:pPr algn="ctr">
+              <a:defRPr>
+                <a:latin typeface="Inter"/>
+              </a:defRPr>
+            </a:pPr>
           </a:p>
         </p:txBody>
       </p:sp>
@@ -3717,6 +3839,9 @@
               </a:defRPr>
             </a:pPr>
             <a:r>
+              <a:rPr>
+                <a:latin typeface="Inter"/>
+              </a:rPr>
               <a:t>Practical implications</a:t>
             </a:r>
           </a:p>
@@ -3763,7 +3888,11 @@
           <a:bodyPr rtlCol="0" anchor="ctr"/>
           <a:lstStyle/>
           <a:p>
-            <a:pPr algn="ctr"/>
+            <a:pPr algn="ctr">
+              <a:defRPr>
+                <a:latin typeface="Inter"/>
+              </a:defRPr>
+            </a:pPr>
           </a:p>
         </p:txBody>
       </p:sp>
@@ -3808,7 +3937,11 @@
           <a:bodyPr rtlCol="0" anchor="ctr"/>
           <a:lstStyle/>
           <a:p>
-            <a:pPr algn="ctr"/>
+            <a:pPr algn="ctr">
+              <a:defRPr>
+                <a:latin typeface="Inter"/>
+              </a:defRPr>
+            </a:pPr>
           </a:p>
         </p:txBody>
       </p:sp>
@@ -3846,6 +3979,9 @@
               </a:defRPr>
             </a:pPr>
             <a:r>
+              <a:rPr>
+                <a:latin typeface="Inter"/>
+              </a:rPr>
               <a:t>03</a:t>
             </a:r>
           </a:p>
@@ -3885,6 +4021,9 @@
               </a:defRPr>
             </a:pPr>
             <a:r>
+              <a:rPr>
+                <a:latin typeface="Inter"/>
+              </a:rPr>
               <a:t>•  Ask for the fee schedule if the report omits it.</a:t>
             </a:r>
           </a:p>
@@ -3931,7 +4070,11 @@
           <a:bodyPr rtlCol="0" anchor="ctr"/>
           <a:lstStyle/>
           <a:p>
-            <a:pPr algn="ctr"/>
+            <a:pPr algn="ctr">
+              <a:defRPr>
+                <a:latin typeface="Inter"/>
+              </a:defRPr>
+            </a:pPr>
           </a:p>
         </p:txBody>
       </p:sp>
@@ -3969,6 +4112,9 @@
               </a:defRPr>
             </a:pPr>
             <a:r>
+              <a:rPr>
+                <a:latin typeface="Inter"/>
+              </a:rPr>
               <a:t>Sources: none cited</a:t>
             </a:r>
           </a:p>
@@ -4008,7 +4154,10 @@
               </a:defRPr>
             </a:pPr>
             <a:r>
-              <a:t>Layout test — not legal advice</a:t>
+              <a:rPr>
+                <a:latin typeface="Inter"/>
+              </a:rPr>
+              <a:t>Layout test — not legal advice · Data as of References as of October 2026</a:t>
             </a:r>
           </a:p>
         </p:txBody>
@@ -4047,6 +4196,9 @@
               </a:defRPr>
             </a:pPr>
             <a:r>
+              <a:rPr>
+                <a:latin typeface="Inter"/>
+              </a:rPr>
               <a:t>4</a:t>
             </a:r>
           </a:p>
@@ -4111,7 +4263,11 @@
           <a:bodyPr rtlCol="0" anchor="ctr"/>
           <a:lstStyle/>
           <a:p>
-            <a:pPr algn="ctr"/>
+            <a:pPr algn="ctr">
+              <a:defRPr>
+                <a:latin typeface="Inter"/>
+              </a:defRPr>
+            </a:pPr>
           </a:p>
         </p:txBody>
       </p:sp>
@@ -4149,6 +4305,9 @@
               </a:defRPr>
             </a:pPr>
             <a:r>
+              <a:rPr>
+                <a:latin typeface="Inter"/>
+              </a:rPr>
               <a:t>Appendix — Sources</a:t>
             </a:r>
           </a:p>
@@ -4195,7 +4354,11 @@
           <a:bodyPr rtlCol="0" anchor="ctr"/>
           <a:lstStyle/>
           <a:p>
-            <a:pPr algn="ctr"/>
+            <a:pPr algn="ctr">
+              <a:defRPr>
+                <a:latin typeface="Inter"/>
+              </a:defRPr>
+            </a:pPr>
           </a:p>
         </p:txBody>
       </p:sp>
@@ -4240,7 +4403,11 @@
           <a:bodyPr rtlCol="0" anchor="ctr"/>
           <a:lstStyle/>
           <a:p>
-            <a:pPr algn="ctr"/>
+            <a:pPr algn="ctr">
+              <a:defRPr>
+                <a:latin typeface="Inter"/>
+              </a:defRPr>
+            </a:pPr>
           </a:p>
         </p:txBody>
       </p:sp>
@@ -4278,6 +4445,9 @@
               </a:defRPr>
             </a:pPr>
             <a:r>
+              <a:rPr>
+                <a:latin typeface="Inter"/>
+              </a:rPr>
               <a:t>A</a:t>
             </a:r>
           </a:p>
@@ -4317,11 +4487,17 @@
               </a:defRPr>
             </a:pPr>
             <a:r>
+              <a:rPr>
+                <a:latin typeface="Inter"/>
+              </a:rPr>
               <a:t>·  Tag  ·  Source  ·  Detail  · </a:t>
             </a:r>
             <a:br/>
             <a:br/>
             <a:r>
+              <a:rPr>
+                <a:latin typeface="Inter"/>
+              </a:rPr>
               <a:t> ·  S1  ·  firms-report-checklist.md  ·  Section A, 4.C.11  ·</a:t>
             </a:r>
           </a:p>
@@ -4368,7 +4544,11 @@
           <a:bodyPr rtlCol="0" anchor="ctr"/>
           <a:lstStyle/>
           <a:p>
-            <a:pPr algn="ctr"/>
+            <a:pPr algn="ctr">
+              <a:defRPr>
+                <a:latin typeface="Inter"/>
+              </a:defRPr>
+            </a:pPr>
           </a:p>
         </p:txBody>
       </p:sp>
@@ -4406,6 +4586,9 @@
               </a:defRPr>
             </a:pPr>
             <a:r>
+              <a:rPr>
+                <a:latin typeface="Inter"/>
+              </a:rPr>
               <a:t>Sources: S1</a:t>
             </a:r>
           </a:p>
@@ -4445,7 +4628,10 @@
               </a:defRPr>
             </a:pPr>
             <a:r>
-              <a:t>Layout test — not legal advice</a:t>
+              <a:rPr>
+                <a:latin typeface="Inter"/>
+              </a:rPr>
+              <a:t>Layout test — not legal advice · Data as of References as of October 2026</a:t>
             </a:r>
           </a:p>
         </p:txBody>
@@ -4484,6 +4670,9 @@
               </a:defRPr>
             </a:pPr>
             <a:r>
+              <a:rPr>
+                <a:latin typeface="Inter"/>
+              </a:rPr>
               <a:t>5</a:t>
             </a:r>
           </a:p>
@@ -4548,7 +4737,11 @@
           <a:bodyPr rtlCol="0" anchor="ctr"/>
           <a:lstStyle/>
           <a:p>
-            <a:pPr algn="ctr"/>
+            <a:pPr algn="ctr">
+              <a:defRPr>
+                <a:latin typeface="Inter"/>
+              </a:defRPr>
+            </a:pPr>
           </a:p>
         </p:txBody>
       </p:sp>
@@ -4586,6 +4779,9 @@
               </a:defRPr>
             </a:pPr>
             <a:r>
+              <a:rPr>
+                <a:latin typeface="Inter"/>
+              </a:rPr>
               <a:t>Appendix — Disclaimer</a:t>
             </a:r>
           </a:p>
@@ -4632,7 +4828,11 @@
           <a:bodyPr rtlCol="0" anchor="ctr"/>
           <a:lstStyle/>
           <a:p>
-            <a:pPr algn="ctr"/>
+            <a:pPr algn="ctr">
+              <a:defRPr>
+                <a:latin typeface="Inter"/>
+              </a:defRPr>
+            </a:pPr>
           </a:p>
         </p:txBody>
       </p:sp>
@@ -4677,7 +4877,11 @@
           <a:bodyPr rtlCol="0" anchor="ctr"/>
           <a:lstStyle/>
           <a:p>
-            <a:pPr algn="ctr"/>
+            <a:pPr algn="ctr">
+              <a:defRPr>
+                <a:latin typeface="Inter"/>
+              </a:defRPr>
+            </a:pPr>
           </a:p>
         </p:txBody>
       </p:sp>
@@ -4715,6 +4919,9 @@
               </a:defRPr>
             </a:pPr>
             <a:r>
+              <a:rPr>
+                <a:latin typeface="Inter"/>
+              </a:rPr>
               <a:t>B</a:t>
             </a:r>
           </a:p>
@@ -4754,6 +4961,9 @@
               </a:defRPr>
             </a:pPr>
             <a:r>
+              <a:rPr>
+                <a:latin typeface="Inter"/>
+              </a:rPr>
               <a:t>Not legal advice.</a:t>
             </a:r>
           </a:p>
@@ -4800,7 +5010,11 @@
           <a:bodyPr rtlCol="0" anchor="ctr"/>
           <a:lstStyle/>
           <a:p>
-            <a:pPr algn="ctr"/>
+            <a:pPr algn="ctr">
+              <a:defRPr>
+                <a:latin typeface="Inter"/>
+              </a:defRPr>
+            </a:pPr>
           </a:p>
         </p:txBody>
       </p:sp>
@@ -4838,6 +5052,9 @@
               </a:defRPr>
             </a:pPr>
             <a:r>
+              <a:rPr>
+                <a:latin typeface="Inter"/>
+              </a:rPr>
               <a:t>Sources: none cited</a:t>
             </a:r>
           </a:p>
@@ -4877,7 +5094,10 @@
               </a:defRPr>
             </a:pPr>
             <a:r>
-              <a:t>Layout test — not legal advice</a:t>
+              <a:rPr>
+                <a:latin typeface="Inter"/>
+              </a:rPr>
+              <a:t>Layout test — not legal advice · Data as of References as of October 2026</a:t>
             </a:r>
           </a:p>
         </p:txBody>
@@ -4916,6 +5136,9 @@
               </a:defRPr>
             </a:pPr>
             <a:r>
+              <a:rPr>
+                <a:latin typeface="Inter"/>
+              </a:rPr>
               <a:t>6</a:t>
             </a:r>
           </a:p>
@@ -4934,34 +5157,34 @@
   <a:themeElements>
     <a:clrScheme name="Office">
       <a:dk1>
-        <a:sysClr val="windowText" lastClr="000000"/>
+        <a:srgbClr val="0D1117"/>
       </a:dk1>
       <a:lt1>
-        <a:sysClr val="window" lastClr="FFFFFF"/>
+        <a:srgbClr val="FFFFFF"/>
       </a:lt1>
       <a:dk2>
-        <a:srgbClr val="1F497D"/>
+        <a:srgbClr val="161C24"/>
       </a:dk2>
       <a:lt2>
-        <a:srgbClr val="EEECE1"/>
+        <a:srgbClr val="F5F7F9"/>
       </a:lt2>
       <a:accent1>
-        <a:srgbClr val="4F81BD"/>
+        <a:srgbClr val="C6F432"/>
       </a:accent1>
       <a:accent2>
-        <a:srgbClr val="C0504D"/>
+        <a:srgbClr val="4F6B00"/>
       </a:accent2>
       <a:accent3>
-        <a:srgbClr val="9BBB59"/>
+        <a:srgbClr val="F2A93B"/>
       </a:accent3>
       <a:accent4>
-        <a:srgbClr val="8064A2"/>
+        <a:srgbClr val="5B8DEF"/>
       </a:accent4>
       <a:accent5>
-        <a:srgbClr val="4BACC6"/>
+        <a:srgbClr val="FF6B5E"/>
       </a:accent5>
       <a:accent6>
-        <a:srgbClr val="F79646"/>
+        <a:srgbClr val="3FB8AF"/>
       </a:accent6>
       <a:hlink>
         <a:srgbClr val="0000FF"/>

</xml_diff>

<commit_message>
Release/gradient skills v3 (#33)
* Refresh golden examples from CI renderer and release 2.8.2

Co-authored-by: Cursor <cursoragent@cursor.com>

* refactor: rename and reroute GradientCIO skills (#32)

Co-authored-by: shbryx <sbryant@gradientao.com>
Co-authored-by: Cursor <cursoragent@cursor.com>

---------

Co-authored-by: shbryx <sbryant@gradientao.com>
Co-authored-by: Cursor <cursoragent@cursor.com>
</commit_message>
<xml_diff>
--- a/plugins/gradient-cio/assets/examples/gradient-gips-standards.pptx
+++ b/plugins/gradient-cio/assets/examples/gradient-gips-standards.pptx
@@ -1,20 +1,20 @@
 
 <file path=ppt/presentation.xml><?xml version="1.0" encoding="utf-8"?>
-<p:presentation xmlns:a="http://schemas.openxmlformats.org/drawingml/2006/main" xmlns:r="http://schemas.openxmlformats.org/officeDocument/2006/relationships" xmlns:p="http://schemas.openxmlformats.org/presentationml/2006/main" saveSubsetFonts="1" autoCompressPictures="0">
-  <p:sldMasterIdLst>
-    <p:sldMasterId id="2147483648" r:id="rId1"/>
-  </p:sldMasterIdLst>
-  <p:sldIdLst>
-    <p:sldId id="256" r:id="rId7"/>
-    <p:sldId id="257" r:id="rId8"/>
-    <p:sldId id="258" r:id="rId9"/>
-    <p:sldId id="259" r:id="rId10"/>
-    <p:sldId id="260" r:id="rId11"/>
-    <p:sldId id="261" r:id="rId12"/>
-  </p:sldIdLst>
-  <p:sldSz cx="12191695" cy="6858000" type="screen4x3"/>
-  <p:notesSz cx="6858000" cy="9144000"/>
-  <p:defaultTextStyle>
+<ns0:presentation xmlns:a="http://schemas.openxmlformats.org/drawingml/2006/main" xmlns:ns0="http://schemas.openxmlformats.org/presentationml/2006/main" xmlns:ns1="http://schemas.openxmlformats.org/officeDocument/2006/relationships" saveSubsetFonts="1" autoCompressPictures="0">
+  <ns0:sldMasterIdLst>
+    <ns0:sldMasterId id="2147483648" ns1:id="rId1"/>
+  </ns0:sldMasterIdLst>
+  <ns0:sldIdLst>
+    <ns0:sldId id="256" ns1:id="rId7"/>
+    <ns0:sldId id="257" ns1:id="rId8"/>
+    <ns0:sldId id="258" ns1:id="rId9"/>
+    <ns0:sldId id="259" ns1:id="rId10"/>
+    <ns0:sldId id="260" ns1:id="rId11"/>
+    <ns0:sldId id="261" ns1:id="rId12"/>
+  </ns0:sldIdLst>
+  <ns0:sldSz cx="12191695" cy="6858000" type="screen16x9"/>
+  <ns0:notesSz cx="6858000" cy="9144000"/>
+  <ns0:defaultTextStyle>
     <a:defPPr>
       <a:defRPr lang="en-US"/>
     </a:defPPr>
@@ -108,8 +108,8 @@
         <a:cs typeface="+mn-cs"/>
       </a:defRPr>
     </a:lvl9pPr>
-  </p:defaultTextStyle>
-</p:presentation>
+  </ns0:defaultTextStyle>
+</ns0:presentation>
 </file>
 
 <file path=ppt/slideLayouts/slideLayout1.xml><?xml version="1.0" encoding="utf-8"?>
@@ -2250,7 +2250,11 @@
           <a:bodyPr rtlCol="0" anchor="ctr"/>
           <a:lstStyle/>
           <a:p>
-            <a:pPr algn="ctr"/>
+            <a:pPr algn="ctr">
+              <a:defRPr>
+                <a:latin typeface="Inter"/>
+              </a:defRPr>
+            </a:pPr>
           </a:p>
         </p:txBody>
       </p:sp>
@@ -2295,7 +2299,11 @@
           <a:bodyPr rtlCol="0" anchor="ctr"/>
           <a:lstStyle/>
           <a:p>
-            <a:pPr algn="ctr"/>
+            <a:pPr algn="ctr">
+              <a:defRPr>
+                <a:latin typeface="Inter"/>
+              </a:defRPr>
+            </a:pPr>
           </a:p>
         </p:txBody>
       </p:sp>
@@ -2308,7 +2316,7 @@
         <p:spPr>
           <a:xfrm>
             <a:off x="685800" y="457200"/>
-            <a:ext cx="2743200" cy="320040"/>
+            <a:ext cx="4754880" cy="320040"/>
           </a:xfrm>
           <a:prstGeom prst="rect">
             <a:avLst/>
@@ -2333,6 +2341,9 @@
               </a:defRPr>
             </a:pPr>
             <a:r>
+              <a:rPr>
+                <a:latin typeface="Inter"/>
+              </a:rPr>
               <a:t>GradientCIO</a:t>
             </a:r>
           </a:p>
@@ -2372,6 +2383,9 @@
               </a:defRPr>
             </a:pPr>
             <a:r>
+              <a:rPr>
+                <a:latin typeface="Inter"/>
+              </a:rPr>
               <a:t>GIPS BRIEFING NOTE</a:t>
             </a:r>
           </a:p>
@@ -2411,6 +2425,9 @@
               </a:defRPr>
             </a:pPr>
             <a:r>
+              <a:rPr>
+                <a:latin typeface="Inter"/>
+              </a:rPr>
               <a:t>What must a GIPS Composite Report disclose about fees?</a:t>
             </a:r>
           </a:p>
@@ -2450,6 +2467,9 @@
               </a:defRPr>
             </a:pPr>
             <a:r>
+              <a:rPr>
+                <a:latin typeface="Inter"/>
+              </a:rPr>
               <a:t>2020 GIPS standards · firms</a:t>
             </a:r>
           </a:p>
@@ -2496,7 +2516,11 @@
           <a:bodyPr rtlCol="0" anchor="ctr"/>
           <a:lstStyle/>
           <a:p>
-            <a:pPr algn="ctr"/>
+            <a:pPr algn="ctr">
+              <a:defRPr>
+                <a:latin typeface="Inter"/>
+              </a:defRPr>
+            </a:pPr>
           </a:p>
         </p:txBody>
       </p:sp>
@@ -2534,6 +2558,9 @@
               </a:defRPr>
             </a:pPr>
             <a:r>
+              <a:rPr>
+                <a:latin typeface="Inter"/>
+              </a:rPr>
               <a:t>Layout test — not legal advice</a:t>
             </a:r>
           </a:p>
@@ -2547,8 +2574,8 @@
         </p:nvSpPr>
         <p:spPr>
           <a:xfrm>
-            <a:off x="9875520" y="6473952"/>
-            <a:ext cx="1645920" cy="182880"/>
+            <a:off x="8778240" y="6473952"/>
+            <a:ext cx="2743200" cy="182880"/>
           </a:xfrm>
           <a:prstGeom prst="rect">
             <a:avLst/>
@@ -2573,6 +2600,9 @@
               </a:defRPr>
             </a:pPr>
             <a:r>
+              <a:rPr>
+                <a:latin typeface="Inter"/>
+              </a:rPr>
               <a:t>GradientCIO.com</a:t>
             </a:r>
           </a:p>
@@ -2637,7 +2667,11 @@
           <a:bodyPr rtlCol="0" anchor="ctr"/>
           <a:lstStyle/>
           <a:p>
-            <a:pPr algn="ctr"/>
+            <a:pPr algn="ctr">
+              <a:defRPr>
+                <a:latin typeface="Inter"/>
+              </a:defRPr>
+            </a:pPr>
           </a:p>
         </p:txBody>
       </p:sp>
@@ -2675,6 +2709,9 @@
               </a:defRPr>
             </a:pPr>
             <a:r>
+              <a:rPr>
+                <a:latin typeface="Inter"/>
+              </a:rPr>
               <a:t>Answer</a:t>
             </a:r>
           </a:p>
@@ -2721,7 +2758,11 @@
           <a:bodyPr rtlCol="0" anchor="ctr"/>
           <a:lstStyle/>
           <a:p>
-            <a:pPr algn="ctr"/>
+            <a:pPr algn="ctr">
+              <a:defRPr>
+                <a:latin typeface="Inter"/>
+              </a:defRPr>
+            </a:pPr>
           </a:p>
         </p:txBody>
       </p:sp>
@@ -2766,7 +2807,11 @@
           <a:bodyPr rtlCol="0" anchor="ctr"/>
           <a:lstStyle/>
           <a:p>
-            <a:pPr algn="ctr"/>
+            <a:pPr algn="ctr">
+              <a:defRPr>
+                <a:latin typeface="Inter"/>
+              </a:defRPr>
+            </a:pPr>
           </a:p>
         </p:txBody>
       </p:sp>
@@ -2804,6 +2849,9 @@
               </a:defRPr>
             </a:pPr>
             <a:r>
+              <a:rPr>
+                <a:latin typeface="Inter"/>
+              </a:rPr>
               <a:t>01</a:t>
             </a:r>
           </a:p>
@@ -2850,7 +2898,11 @@
           <a:bodyPr rtlCol="0" anchor="ctr"/>
           <a:lstStyle/>
           <a:p>
-            <a:pPr algn="ctr"/>
+            <a:pPr algn="ctr">
+              <a:defRPr>
+                <a:latin typeface="Inter"/>
+              </a:defRPr>
+            </a:pPr>
           </a:p>
         </p:txBody>
       </p:sp>
@@ -2895,7 +2947,11 @@
           <a:bodyPr rtlCol="0" anchor="ctr"/>
           <a:lstStyle/>
           <a:p>
-            <a:pPr algn="ctr"/>
+            <a:pPr algn="ctr">
+              <a:defRPr>
+                <a:latin typeface="Inter"/>
+              </a:defRPr>
+            </a:pPr>
           </a:p>
         </p:txBody>
       </p:sp>
@@ -2933,6 +2989,9 @@
               </a:defRPr>
             </a:pPr>
             <a:r>
+              <a:rPr>
+                <a:latin typeface="Inter"/>
+              </a:rPr>
               <a:t>Short answer</a:t>
             </a:r>
           </a:p>
@@ -2972,6 +3031,9 @@
               </a:defRPr>
             </a:pPr>
             <a:r>
+              <a:rPr>
+                <a:latin typeface="Inter"/>
+              </a:rPr>
               <a:t>Disclose the fee schedule (4.C.11) and label returns gross or net (4.A.3) [S1].</a:t>
             </a:r>
           </a:p>
@@ -3011,6 +3073,9 @@
               </a:defRPr>
             </a:pPr>
             <a:r>
+              <a:rPr>
+                <a:latin typeface="Inter"/>
+              </a:rPr>
               <a:t>A GIPS Composite Report must disclose the fee schedule appropriate to the report's prospective client (4.C.11) and state whether returns are gross or net of fees, with what fees were deducted.</a:t>
             </a:r>
           </a:p>
@@ -3057,7 +3122,11 @@
           <a:bodyPr rtlCol="0" anchor="ctr"/>
           <a:lstStyle/>
           <a:p>
-            <a:pPr algn="ctr"/>
+            <a:pPr algn="ctr">
+              <a:defRPr>
+                <a:latin typeface="Inter"/>
+              </a:defRPr>
+            </a:pPr>
           </a:p>
         </p:txBody>
       </p:sp>
@@ -3095,6 +3164,9 @@
               </a:defRPr>
             </a:pPr>
             <a:r>
+              <a:rPr>
+                <a:latin typeface="Inter"/>
+              </a:rPr>
               <a:t>Sources: S1</a:t>
             </a:r>
           </a:p>
@@ -3134,7 +3206,10 @@
               </a:defRPr>
             </a:pPr>
             <a:r>
-              <a:t>Layout test — not legal advice</a:t>
+              <a:rPr>
+                <a:latin typeface="Inter"/>
+              </a:rPr>
+              <a:t>Layout test — not legal advice · Data as of References as of October 2026</a:t>
             </a:r>
           </a:p>
         </p:txBody>
@@ -3173,6 +3248,9 @@
               </a:defRPr>
             </a:pPr>
             <a:r>
+              <a:rPr>
+                <a:latin typeface="Inter"/>
+              </a:rPr>
               <a:t>2</a:t>
             </a:r>
           </a:p>
@@ -3237,7 +3315,11 @@
           <a:bodyPr rtlCol="0" anchor="ctr"/>
           <a:lstStyle/>
           <a:p>
-            <a:pPr algn="ctr"/>
+            <a:pPr algn="ctr">
+              <a:defRPr>
+                <a:latin typeface="Inter"/>
+              </a:defRPr>
+            </a:pPr>
           </a:p>
         </p:txBody>
       </p:sp>
@@ -3275,6 +3357,9 @@
               </a:defRPr>
             </a:pPr>
             <a:r>
+              <a:rPr>
+                <a:latin typeface="Inter"/>
+              </a:rPr>
               <a:t>Requirements</a:t>
             </a:r>
           </a:p>
@@ -3321,7 +3406,11 @@
           <a:bodyPr rtlCol="0" anchor="ctr"/>
           <a:lstStyle/>
           <a:p>
-            <a:pPr algn="ctr"/>
+            <a:pPr algn="ctr">
+              <a:defRPr>
+                <a:latin typeface="Inter"/>
+              </a:defRPr>
+            </a:pPr>
           </a:p>
         </p:txBody>
       </p:sp>
@@ -3366,7 +3455,11 @@
           <a:bodyPr rtlCol="0" anchor="ctr"/>
           <a:lstStyle/>
           <a:p>
-            <a:pPr algn="ctr"/>
+            <a:pPr algn="ctr">
+              <a:defRPr>
+                <a:latin typeface="Inter"/>
+              </a:defRPr>
+            </a:pPr>
           </a:p>
         </p:txBody>
       </p:sp>
@@ -3404,6 +3497,9 @@
               </a:defRPr>
             </a:pPr>
             <a:r>
+              <a:rPr>
+                <a:latin typeface="Inter"/>
+              </a:rPr>
               <a:t>02</a:t>
             </a:r>
           </a:p>
@@ -3443,16 +3539,25 @@
               </a:defRPr>
             </a:pPr>
             <a:r>
+              <a:rPr>
+                <a:latin typeface="Inter"/>
+              </a:rPr>
               <a:t>·  Requirement  ·  Provision  ·  Applies to  ·  Notes  · </a:t>
             </a:r>
             <a:br/>
             <a:br/>
             <a:r>
+              <a:rPr>
+                <a:latin typeface="Inter"/>
+              </a:rPr>
               <a:t> ·  Current fee schedule  ·  4.C.11  ·  Composite reports  ·  Appropriate to the prospective client  · </a:t>
             </a:r>
             <a:br/>
             <a:br/>
             <a:r>
+              <a:rPr>
+                <a:latin typeface="Inter"/>
+              </a:rPr>
               <a:t> ·  Gross/net labelling  ·  4.A.3  ·  All reports  ·  Label every return series  ·</a:t>
             </a:r>
           </a:p>
@@ -3499,7 +3604,11 @@
           <a:bodyPr rtlCol="0" anchor="ctr"/>
           <a:lstStyle/>
           <a:p>
-            <a:pPr algn="ctr"/>
+            <a:pPr algn="ctr">
+              <a:defRPr>
+                <a:latin typeface="Inter"/>
+              </a:defRPr>
+            </a:pPr>
           </a:p>
         </p:txBody>
       </p:sp>
@@ -3537,6 +3646,9 @@
               </a:defRPr>
             </a:pPr>
             <a:r>
+              <a:rPr>
+                <a:latin typeface="Inter"/>
+              </a:rPr>
               <a:t>Sources: none cited</a:t>
             </a:r>
           </a:p>
@@ -3576,7 +3688,10 @@
               </a:defRPr>
             </a:pPr>
             <a:r>
-              <a:t>Layout test — not legal advice</a:t>
+              <a:rPr>
+                <a:latin typeface="Inter"/>
+              </a:rPr>
+              <a:t>Layout test — not legal advice · Data as of References as of October 2026</a:t>
             </a:r>
           </a:p>
         </p:txBody>
@@ -3615,6 +3730,9 @@
               </a:defRPr>
             </a:pPr>
             <a:r>
+              <a:rPr>
+                <a:latin typeface="Inter"/>
+              </a:rPr>
               <a:t>3</a:t>
             </a:r>
           </a:p>
@@ -3679,7 +3797,11 @@
           <a:bodyPr rtlCol="0" anchor="ctr"/>
           <a:lstStyle/>
           <a:p>
-            <a:pPr algn="ctr"/>
+            <a:pPr algn="ctr">
+              <a:defRPr>
+                <a:latin typeface="Inter"/>
+              </a:defRPr>
+            </a:pPr>
           </a:p>
         </p:txBody>
       </p:sp>
@@ -3717,6 +3839,9 @@
               </a:defRPr>
             </a:pPr>
             <a:r>
+              <a:rPr>
+                <a:latin typeface="Inter"/>
+              </a:rPr>
               <a:t>Practical implications</a:t>
             </a:r>
           </a:p>
@@ -3763,7 +3888,11 @@
           <a:bodyPr rtlCol="0" anchor="ctr"/>
           <a:lstStyle/>
           <a:p>
-            <a:pPr algn="ctr"/>
+            <a:pPr algn="ctr">
+              <a:defRPr>
+                <a:latin typeface="Inter"/>
+              </a:defRPr>
+            </a:pPr>
           </a:p>
         </p:txBody>
       </p:sp>
@@ -3808,7 +3937,11 @@
           <a:bodyPr rtlCol="0" anchor="ctr"/>
           <a:lstStyle/>
           <a:p>
-            <a:pPr algn="ctr"/>
+            <a:pPr algn="ctr">
+              <a:defRPr>
+                <a:latin typeface="Inter"/>
+              </a:defRPr>
+            </a:pPr>
           </a:p>
         </p:txBody>
       </p:sp>
@@ -3846,6 +3979,9 @@
               </a:defRPr>
             </a:pPr>
             <a:r>
+              <a:rPr>
+                <a:latin typeface="Inter"/>
+              </a:rPr>
               <a:t>03</a:t>
             </a:r>
           </a:p>
@@ -3885,6 +4021,9 @@
               </a:defRPr>
             </a:pPr>
             <a:r>
+              <a:rPr>
+                <a:latin typeface="Inter"/>
+              </a:rPr>
               <a:t>•  Ask for the fee schedule if the report omits it.</a:t>
             </a:r>
           </a:p>
@@ -3931,7 +4070,11 @@
           <a:bodyPr rtlCol="0" anchor="ctr"/>
           <a:lstStyle/>
           <a:p>
-            <a:pPr algn="ctr"/>
+            <a:pPr algn="ctr">
+              <a:defRPr>
+                <a:latin typeface="Inter"/>
+              </a:defRPr>
+            </a:pPr>
           </a:p>
         </p:txBody>
       </p:sp>
@@ -3969,6 +4112,9 @@
               </a:defRPr>
             </a:pPr>
             <a:r>
+              <a:rPr>
+                <a:latin typeface="Inter"/>
+              </a:rPr>
               <a:t>Sources: none cited</a:t>
             </a:r>
           </a:p>
@@ -4008,7 +4154,10 @@
               </a:defRPr>
             </a:pPr>
             <a:r>
-              <a:t>Layout test — not legal advice</a:t>
+              <a:rPr>
+                <a:latin typeface="Inter"/>
+              </a:rPr>
+              <a:t>Layout test — not legal advice · Data as of References as of October 2026</a:t>
             </a:r>
           </a:p>
         </p:txBody>
@@ -4047,6 +4196,9 @@
               </a:defRPr>
             </a:pPr>
             <a:r>
+              <a:rPr>
+                <a:latin typeface="Inter"/>
+              </a:rPr>
               <a:t>4</a:t>
             </a:r>
           </a:p>
@@ -4111,7 +4263,11 @@
           <a:bodyPr rtlCol="0" anchor="ctr"/>
           <a:lstStyle/>
           <a:p>
-            <a:pPr algn="ctr"/>
+            <a:pPr algn="ctr">
+              <a:defRPr>
+                <a:latin typeface="Inter"/>
+              </a:defRPr>
+            </a:pPr>
           </a:p>
         </p:txBody>
       </p:sp>
@@ -4149,6 +4305,9 @@
               </a:defRPr>
             </a:pPr>
             <a:r>
+              <a:rPr>
+                <a:latin typeface="Inter"/>
+              </a:rPr>
               <a:t>Appendix — Sources</a:t>
             </a:r>
           </a:p>
@@ -4195,7 +4354,11 @@
           <a:bodyPr rtlCol="0" anchor="ctr"/>
           <a:lstStyle/>
           <a:p>
-            <a:pPr algn="ctr"/>
+            <a:pPr algn="ctr">
+              <a:defRPr>
+                <a:latin typeface="Inter"/>
+              </a:defRPr>
+            </a:pPr>
           </a:p>
         </p:txBody>
       </p:sp>
@@ -4240,7 +4403,11 @@
           <a:bodyPr rtlCol="0" anchor="ctr"/>
           <a:lstStyle/>
           <a:p>
-            <a:pPr algn="ctr"/>
+            <a:pPr algn="ctr">
+              <a:defRPr>
+                <a:latin typeface="Inter"/>
+              </a:defRPr>
+            </a:pPr>
           </a:p>
         </p:txBody>
       </p:sp>
@@ -4278,6 +4445,9 @@
               </a:defRPr>
             </a:pPr>
             <a:r>
+              <a:rPr>
+                <a:latin typeface="Inter"/>
+              </a:rPr>
               <a:t>A</a:t>
             </a:r>
           </a:p>
@@ -4317,11 +4487,17 @@
               </a:defRPr>
             </a:pPr>
             <a:r>
+              <a:rPr>
+                <a:latin typeface="Inter"/>
+              </a:rPr>
               <a:t>·  Tag  ·  Source  ·  Detail  · </a:t>
             </a:r>
             <a:br/>
             <a:br/>
             <a:r>
+              <a:rPr>
+                <a:latin typeface="Inter"/>
+              </a:rPr>
               <a:t> ·  S1  ·  firms-report-checklist.md  ·  Section A, 4.C.11  ·</a:t>
             </a:r>
           </a:p>
@@ -4368,7 +4544,11 @@
           <a:bodyPr rtlCol="0" anchor="ctr"/>
           <a:lstStyle/>
           <a:p>
-            <a:pPr algn="ctr"/>
+            <a:pPr algn="ctr">
+              <a:defRPr>
+                <a:latin typeface="Inter"/>
+              </a:defRPr>
+            </a:pPr>
           </a:p>
         </p:txBody>
       </p:sp>
@@ -4406,6 +4586,9 @@
               </a:defRPr>
             </a:pPr>
             <a:r>
+              <a:rPr>
+                <a:latin typeface="Inter"/>
+              </a:rPr>
               <a:t>Sources: S1</a:t>
             </a:r>
           </a:p>
@@ -4445,7 +4628,10 @@
               </a:defRPr>
             </a:pPr>
             <a:r>
-              <a:t>Layout test — not legal advice</a:t>
+              <a:rPr>
+                <a:latin typeface="Inter"/>
+              </a:rPr>
+              <a:t>Layout test — not legal advice · Data as of References as of October 2026</a:t>
             </a:r>
           </a:p>
         </p:txBody>
@@ -4484,6 +4670,9 @@
               </a:defRPr>
             </a:pPr>
             <a:r>
+              <a:rPr>
+                <a:latin typeface="Inter"/>
+              </a:rPr>
               <a:t>5</a:t>
             </a:r>
           </a:p>
@@ -4548,7 +4737,11 @@
           <a:bodyPr rtlCol="0" anchor="ctr"/>
           <a:lstStyle/>
           <a:p>
-            <a:pPr algn="ctr"/>
+            <a:pPr algn="ctr">
+              <a:defRPr>
+                <a:latin typeface="Inter"/>
+              </a:defRPr>
+            </a:pPr>
           </a:p>
         </p:txBody>
       </p:sp>
@@ -4586,6 +4779,9 @@
               </a:defRPr>
             </a:pPr>
             <a:r>
+              <a:rPr>
+                <a:latin typeface="Inter"/>
+              </a:rPr>
               <a:t>Appendix — Disclaimer</a:t>
             </a:r>
           </a:p>
@@ -4632,7 +4828,11 @@
           <a:bodyPr rtlCol="0" anchor="ctr"/>
           <a:lstStyle/>
           <a:p>
-            <a:pPr algn="ctr"/>
+            <a:pPr algn="ctr">
+              <a:defRPr>
+                <a:latin typeface="Inter"/>
+              </a:defRPr>
+            </a:pPr>
           </a:p>
         </p:txBody>
       </p:sp>
@@ -4677,7 +4877,11 @@
           <a:bodyPr rtlCol="0" anchor="ctr"/>
           <a:lstStyle/>
           <a:p>
-            <a:pPr algn="ctr"/>
+            <a:pPr algn="ctr">
+              <a:defRPr>
+                <a:latin typeface="Inter"/>
+              </a:defRPr>
+            </a:pPr>
           </a:p>
         </p:txBody>
       </p:sp>
@@ -4715,6 +4919,9 @@
               </a:defRPr>
             </a:pPr>
             <a:r>
+              <a:rPr>
+                <a:latin typeface="Inter"/>
+              </a:rPr>
               <a:t>B</a:t>
             </a:r>
           </a:p>
@@ -4754,6 +4961,9 @@
               </a:defRPr>
             </a:pPr>
             <a:r>
+              <a:rPr>
+                <a:latin typeface="Inter"/>
+              </a:rPr>
               <a:t>Not legal advice.</a:t>
             </a:r>
           </a:p>
@@ -4800,7 +5010,11 @@
           <a:bodyPr rtlCol="0" anchor="ctr"/>
           <a:lstStyle/>
           <a:p>
-            <a:pPr algn="ctr"/>
+            <a:pPr algn="ctr">
+              <a:defRPr>
+                <a:latin typeface="Inter"/>
+              </a:defRPr>
+            </a:pPr>
           </a:p>
         </p:txBody>
       </p:sp>
@@ -4838,6 +5052,9 @@
               </a:defRPr>
             </a:pPr>
             <a:r>
+              <a:rPr>
+                <a:latin typeface="Inter"/>
+              </a:rPr>
               <a:t>Sources: none cited</a:t>
             </a:r>
           </a:p>
@@ -4877,7 +5094,10 @@
               </a:defRPr>
             </a:pPr>
             <a:r>
-              <a:t>Layout test — not legal advice</a:t>
+              <a:rPr>
+                <a:latin typeface="Inter"/>
+              </a:rPr>
+              <a:t>Layout test — not legal advice · Data as of References as of October 2026</a:t>
             </a:r>
           </a:p>
         </p:txBody>
@@ -4916,6 +5136,9 @@
               </a:defRPr>
             </a:pPr>
             <a:r>
+              <a:rPr>
+                <a:latin typeface="Inter"/>
+              </a:rPr>
               <a:t>6</a:t>
             </a:r>
           </a:p>
@@ -4934,34 +5157,34 @@
   <a:themeElements>
     <a:clrScheme name="Office">
       <a:dk1>
-        <a:sysClr val="windowText" lastClr="000000"/>
+        <a:srgbClr val="0D1117"/>
       </a:dk1>
       <a:lt1>
-        <a:sysClr val="window" lastClr="FFFFFF"/>
+        <a:srgbClr val="FFFFFF"/>
       </a:lt1>
       <a:dk2>
-        <a:srgbClr val="1F497D"/>
+        <a:srgbClr val="161C24"/>
       </a:dk2>
       <a:lt2>
-        <a:srgbClr val="EEECE1"/>
+        <a:srgbClr val="F5F7F9"/>
       </a:lt2>
       <a:accent1>
-        <a:srgbClr val="4F81BD"/>
+        <a:srgbClr val="C6F432"/>
       </a:accent1>
       <a:accent2>
-        <a:srgbClr val="C0504D"/>
+        <a:srgbClr val="4F6B00"/>
       </a:accent2>
       <a:accent3>
-        <a:srgbClr val="9BBB59"/>
+        <a:srgbClr val="F2A93B"/>
       </a:accent3>
       <a:accent4>
-        <a:srgbClr val="8064A2"/>
+        <a:srgbClr val="5B8DEF"/>
       </a:accent4>
       <a:accent5>
-        <a:srgbClr val="4BACC6"/>
+        <a:srgbClr val="FF6B5E"/>
       </a:accent5>
       <a:accent6>
-        <a:srgbClr val="F79646"/>
+        <a:srgbClr val="3FB8AF"/>
       </a:accent6>
       <a:hlink>
         <a:srgbClr val="0000FF"/>

</xml_diff>